<commit_message>
brand: synapse mark, connectomics motif on decks, new tagline
Replace the trail-and-node mark with a synapse (axon terminal with
vesicles contacting a dendritic spine), which is specific to the field
and still reads at 16 px. Add nt-motif-synapse.svg and use it behind
the title and closing slides in both the Marp theme and the PowerPoint
template; put the mark in every slide footer. Recommend the tagline
"Mapping connections. Making connections." and list the alternatives
considered in the brand guide.

Co-Authored-By: Claude Fable 5.1 <noreply@anthropic.com>
Claude-Session: https://claude.ai/code/session_01HvMCpCZakorJeicbJUmznj
</commit_message>
<xml_diff>
--- a/assets/brand/NeuroTrailblazers-slide-template.pptx
+++ b/assets/brand/NeuroTrailblazers-slide-template.pptx
@@ -513,7 +513,7 @@
           <a:p>
             <a:r>
               <a:rPr lang="en-US" dirty="0"/>
-              <a:t>TITLE SLIDE. Keep the amber pill for the unit/module label. Do not add a second accent colour. The background image carries the trail motif; do not stack a logo on top of it.</a:t>
+              <a:t>TITLE SLIDE. Keep the amber pill for the unit/module label. Do not add a second accent colour. The background carries the synapse motif (dendrite with spines, arriving axons, one lit synapse); do not stack a logo on top of it.</a:t>
             </a:r>
             <a:endParaRPr lang="en-US" dirty="0"/>
           </a:p>
@@ -1577,15 +1577,39 @@
           <a:chExt cx="0" cy="0"/>
         </a:xfrm>
       </p:grpSpPr>
-      <p:sp>
-        <p:nvSpPr>
-          <p:cNvPr id="2" name="Text 0"/>
+      <p:pic>
+        <p:nvPicPr>
+          <p:cNvPr id="2" name="Image 0" descr="preencoded.png">    </p:cNvPr>
+          <p:cNvPicPr>
+            <a:picLocks noChangeAspect="1"/>
+          </p:cNvPicPr>
+          <p:nvPr/>
+        </p:nvPicPr>
+        <p:blipFill>
+          <a:blip r:embed="rId1"/>
+          <a:stretch>
+            <a:fillRect/>
+          </a:stretch>
+        </p:blipFill>
+        <p:spPr>
+          <a:xfrm>
+            <a:off x="640080" y="6382512"/>
+            <a:ext cx="274320" cy="274320"/>
+          </a:xfrm>
+          <a:prstGeom prst="rect">
+            <a:avLst/>
+          </a:prstGeom>
+        </p:spPr>
+      </p:pic>
+      <p:sp>
+        <p:nvSpPr>
+          <p:cNvPr id="3" name="Text 0"/>
           <p:cNvSpPr txBox="1"/>
           <p:nvPr/>
         </p:nvSpPr>
         <p:spPr>
           <a:xfrm>
-            <a:off x="640080" y="6400800"/>
+            <a:off x="1005840" y="6400800"/>
             <a:ext cx="3657600" cy="274320"/>
           </a:xfrm>
           <a:prstGeom prst="rect">
@@ -1696,15 +1720,39 @@
           <a:chExt cx="0" cy="0"/>
         </a:xfrm>
       </p:grpSpPr>
-      <p:sp>
-        <p:nvSpPr>
-          <p:cNvPr id="2" name="Text 0"/>
+      <p:pic>
+        <p:nvPicPr>
+          <p:cNvPr id="2" name="Image 0" descr="preencoded.png">    </p:cNvPr>
+          <p:cNvPicPr>
+            <a:picLocks noChangeAspect="1"/>
+          </p:cNvPicPr>
+          <p:nvPr/>
+        </p:nvPicPr>
+        <p:blipFill>
+          <a:blip r:embed="rId1"/>
+          <a:stretch>
+            <a:fillRect/>
+          </a:stretch>
+        </p:blipFill>
+        <p:spPr>
+          <a:xfrm>
+            <a:off x="640080" y="6382512"/>
+            <a:ext cx="274320" cy="274320"/>
+          </a:xfrm>
+          <a:prstGeom prst="rect">
+            <a:avLst/>
+          </a:prstGeom>
+        </p:spPr>
+      </p:pic>
+      <p:sp>
+        <p:nvSpPr>
+          <p:cNvPr id="3" name="Text 0"/>
           <p:cNvSpPr txBox="1"/>
           <p:nvPr/>
         </p:nvSpPr>
         <p:spPr>
           <a:xfrm>
-            <a:off x="640080" y="6400800"/>
+            <a:off x="1005840" y="6400800"/>
             <a:ext cx="3657600" cy="274320"/>
           </a:xfrm>
           <a:prstGeom prst="rect">
@@ -1815,15 +1863,39 @@
           <a:chExt cx="0" cy="0"/>
         </a:xfrm>
       </p:grpSpPr>
-      <p:sp>
-        <p:nvSpPr>
-          <p:cNvPr id="2" name="Text 0"/>
+      <p:pic>
+        <p:nvPicPr>
+          <p:cNvPr id="2" name="Image 0" descr="preencoded.png">    </p:cNvPr>
+          <p:cNvPicPr>
+            <a:picLocks noChangeAspect="1"/>
+          </p:cNvPicPr>
+          <p:nvPr/>
+        </p:nvPicPr>
+        <p:blipFill>
+          <a:blip r:embed="rId1"/>
+          <a:stretch>
+            <a:fillRect/>
+          </a:stretch>
+        </p:blipFill>
+        <p:spPr>
+          <a:xfrm>
+            <a:off x="640080" y="6382512"/>
+            <a:ext cx="274320" cy="274320"/>
+          </a:xfrm>
+          <a:prstGeom prst="rect">
+            <a:avLst/>
+          </a:prstGeom>
+        </p:spPr>
+      </p:pic>
+      <p:sp>
+        <p:nvSpPr>
+          <p:cNvPr id="3" name="Text 0"/>
           <p:cNvSpPr txBox="1"/>
           <p:nvPr/>
         </p:nvSpPr>
         <p:spPr>
           <a:xfrm>
-            <a:off x="640080" y="6400800"/>
+            <a:off x="1005840" y="6400800"/>
             <a:ext cx="3657600" cy="274320"/>
           </a:xfrm>
           <a:prstGeom prst="rect">
@@ -3264,8 +3336,8 @@
         </p:nvSpPr>
         <p:spPr>
           <a:xfrm>
-            <a:off x="640080" y="2468880"/>
-            <a:ext cx="9144000" cy="1097280"/>
+            <a:off x="640080" y="2286000"/>
+            <a:ext cx="10515600" cy="1280160"/>
           </a:xfrm>
           <a:prstGeom prst="rect">
             <a:avLst/>
@@ -3281,7 +3353,7 @@
               <a:buNone/>
             </a:pPr>
             <a:r>
-              <a:rPr lang="en-US" sz="5400" b="1" dirty="0">
+              <a:rPr lang="en-US" sz="4800" b="1" dirty="0">
                 <a:solidFill>
                   <a:srgbClr val="FFFFFF"/>
                 </a:solidFill>
@@ -3289,9 +3361,9 @@
                 <a:ea typeface="Arial" pitchFamily="34" charset="-122"/>
                 <a:cs typeface="Arial" pitchFamily="34" charset="-120"/>
               </a:rPr>
-              <a:t>Thank you</a:t>
-            </a:r>
-            <a:endParaRPr lang="en-US" sz="5400" dirty="0"/>
+              <a:t>Mapping connections. Making connections.</a:t>
+            </a:r>
+            <a:endParaRPr lang="en-US" sz="4800" dirty="0"/>
           </a:p>
         </p:txBody>
       </p:sp>

</xml_diff>